<commit_message>
fix: retrieval fallback to last active topic; validate classifier output; clean AMD/Gemma pitch
</commit_message>
<xml_diff>
--- a/PADAYON_Pitch_Deck.pptx
+++ b/PADAYON_Pitch_Deck.pptx
@@ -5250,7 +5250,7 @@
               </a:defRPr>
             </a:pPr>
             <a:r>
-              <a:t>Powered by Gemma on AMD / Fireworks AI</a:t>
+              <a:t>AMD-Ready Architecture with Gemma Support</a:t>
             </a:r>
           </a:p>
         </p:txBody>
@@ -5288,7 +5288,7 @@
               </a:defRPr>
             </a:pPr>
             <a:r>
-              <a:t>• Default pipeline runs on Fireworks AI serverless models (AMD-hosted DeepSeek-V4 / Kimi-K2.5).</a:t>
+              <a:t>• Production runtime: Fireworks AI API — Fireworks is an AMD partner hosting fast, serverless models on AMD infrastructure.</a:t>
             </a:r>
           </a:p>
           <a:p>
@@ -5303,7 +5303,7 @@
               </a:defRPr>
             </a:pPr>
             <a:r>
-              <a:t>• Demo toggle switches to Gemma 4 31B Instruct via Fireworks on-demand for high-quality teaching.</a:t>
+              <a:t>• Default pipeline uses Fireworks serverless models (DeepSeek-V4 / Kimi-K2.5) for reliability and speed.</a:t>
             </a:r>
           </a:p>
           <a:p>
@@ -5318,7 +5318,7 @@
               </a:defRPr>
             </a:pPr>
             <a:r>
-              <a:t>• Automatic fallback keeps the demo stable if Gemma is scaled down or unavailable.</a:t>
+              <a:t>• Demo toggle switches to Gemma 3/4 when an endpoint is available via Fireworks on-demand or AMD Developer Cloud GPU pod.</a:t>
             </a:r>
           </a:p>
           <a:p>
@@ -5333,7 +5333,7 @@
               </a:defRPr>
             </a:pPr>
             <a:r>
-              <a:t>• Built with Next.js + Supabase + Tailwind, containerized with Docker for submission.</a:t>
+              <a:t>• Automatic fallback keeps the demo stable if Gemma is unreachable.</a:t>
             </a:r>
           </a:p>
           <a:p>
@@ -5348,7 +5348,22 @@
               </a:defRPr>
             </a:pPr>
             <a:r>
-              <a:t>• Qualifies for both Unicorn Track and Best AMD-Hosted Gemma Project ($2,000 prize).</a:t>
+              <a:t>• Containerized with Docker and built with Next.js + Supabase + Tailwind.</a:t>
+            </a:r>
+          </a:p>
+          <a:p>
+            <a:pPr>
+              <a:spcAft>
+                <a:spcPts val="1200"/>
+              </a:spcAft>
+              <a:defRPr sz="2000">
+                <a:solidFill>
+                  <a:srgbClr val="334155"/>
+                </a:solidFill>
+              </a:defRPr>
+            </a:pPr>
+            <a:r>
+              <a:t>• Competes in Unicorn Track and Best AMD-Hosted Gemma Project.</a:t>
             </a:r>
           </a:p>
         </p:txBody>

</xml_diff>